<commit_message>
Remove the extended three-session version
The one-hour notebook is the only version now. Delete extended/ and the
series-only build code (p_carry.py, p9.py, per-session branches), and
drop every pointer to extended/ from the README, notebook and deck.

Co-Authored-By: Claude Opus 5.5 <noreply@anthropic.com>
</commit_message>
<xml_diff>
--- a/slides/TBio_UDL_Ch1-8_OneHour.pptx
+++ b/slides/TBio_UDL_Ch1-8_OneHour.pptx
@@ -10509,31 +10509,6 @@
                 <a:latin typeface="Calibri"/>
               </a:rPr>
               <a:t>Skip the two challenges first. Stuck? Run the solution cell so later parts work.</a:t>
-            </a:r>
-          </a:p>
-          <a:p>
-            <a:pPr algn="l">
-              <a:spcAft>
-                <a:spcPts val="600"/>
-              </a:spcAft>
-            </a:pPr>
-            <a:r>
-              <a:rPr sz="1500" b="1" i="0">
-                <a:solidFill>
-                  <a:srgbClr val="008759"/>
-                </a:solidFill>
-                <a:latin typeface="Calibri"/>
-              </a:rPr>
-              <a:t>Want more? </a:t>
-            </a:r>
-            <a:r>
-              <a:rPr sz="1500" b="0" i="0">
-                <a:solidFill>
-                  <a:srgbClr val="404040"/>
-                </a:solidFill>
-                <a:latin typeface="Calibri"/>
-              </a:rPr>
-              <a:t>The repo's extended/ folder has the full version: 35 puzzles and a capstone.</a:t>
             </a:r>
           </a:p>
         </p:txBody>

</xml_diff>